<commit_message>
all-slides-with-answers.pdf all-slides.pdf code.zip gui.pdf gui.pptx
</commit_message>
<xml_diff>
--- a/ipsa/slides/gui.pptx
+++ b/ipsa/slides/gui.pptx
@@ -134,29 +134,153 @@
 </p:presentation>
 </file>
 
+<file path=ppt/revisionInfo.xml><?xml version="1.0" encoding="utf-8"?>
+<p1510:revInfo xmlns:a="http://schemas.openxmlformats.org/drawingml/2006/main" xmlns:r="http://schemas.openxmlformats.org/officeDocument/2006/relationships" xmlns:p1510="http://schemas.microsoft.com/office/powerpoint/2015/10/main">
+  <p1510:revLst>
+    <p1510:client id="{C4701B71-9891-473F-AD59-47BF21EE949C}" v="3" dt="2026-05-03T20:11:02.723"/>
+  </p1510:revLst>
+</p1510:revInfo>
+</file>
+
 <file path=ppt/changesInfos/changesInfo1.xml><?xml version="1.0" encoding="utf-8"?>
 <pc:chgInfo xmlns:a="http://schemas.openxmlformats.org/drawingml/2006/main" xmlns:r="http://schemas.openxmlformats.org/officeDocument/2006/relationships" xmlns:ac="http://schemas.microsoft.com/office/drawing/2013/main/command" xmlns:pc="http://schemas.microsoft.com/office/powerpoint/2013/main/command">
   <pc:docChgLst>
     <pc:chgData name="Gerth Stølting Brodal" userId="04ef4784-6591-4f86-a140-f5c3b108582a" providerId="ADAL" clId="{73BAC7D6-516A-44B5-B4B0-C7B08CA8B392}"/>
-    <pc:docChg chg="modSld">
-      <pc:chgData name="Gerth Stølting Brodal" userId="04ef4784-6591-4f86-a140-f5c3b108582a" providerId="ADAL" clId="{73BAC7D6-516A-44B5-B4B0-C7B08CA8B392}" dt="2026-03-18T13:07:10.753" v="5" actId="20577"/>
+    <pc:docChg chg="undo custSel modSld">
+      <pc:chgData name="Gerth Stølting Brodal" userId="04ef4784-6591-4f86-a140-f5c3b108582a" providerId="ADAL" clId="{73BAC7D6-516A-44B5-B4B0-C7B08CA8B392}" dt="2026-05-03T20:40:48.374" v="78" actId="478"/>
       <pc:docMkLst>
         <pc:docMk/>
       </pc:docMkLst>
-      <pc:sldChg chg="modSp mod">
-        <pc:chgData name="Gerth Stølting Brodal" userId="04ef4784-6591-4f86-a140-f5c3b108582a" providerId="ADAL" clId="{73BAC7D6-516A-44B5-B4B0-C7B08CA8B392}" dt="2026-03-18T13:07:10.753" v="5" actId="20577"/>
+      <pc:sldChg chg="modSp modAnim">
+        <pc:chgData name="Gerth Stølting Brodal" userId="04ef4784-6591-4f86-a140-f5c3b108582a" providerId="ADAL" clId="{73BAC7D6-516A-44B5-B4B0-C7B08CA8B392}" dt="2026-05-03T20:10:34.683" v="53"/>
+        <pc:sldMkLst>
+          <pc:docMk/>
+          <pc:sldMk cId="615192665" sldId="722"/>
+        </pc:sldMkLst>
+        <pc:spChg chg="mod">
+          <ac:chgData name="Gerth Stølting Brodal" userId="04ef4784-6591-4f86-a140-f5c3b108582a" providerId="ADAL" clId="{73BAC7D6-516A-44B5-B4B0-C7B08CA8B392}" dt="2026-05-03T20:10:33.331" v="52"/>
+          <ac:spMkLst>
+            <pc:docMk/>
+            <pc:sldMk cId="615192665" sldId="722"/>
+            <ac:spMk id="3" creationId="{00000000-0000-0000-0000-000000000000}"/>
+          </ac:spMkLst>
+        </pc:spChg>
+      </pc:sldChg>
+      <pc:sldChg chg="addSp delSp modSp mod">
+        <pc:chgData name="Gerth Stølting Brodal" userId="04ef4784-6591-4f86-a140-f5c3b108582a" providerId="ADAL" clId="{73BAC7D6-516A-44B5-B4B0-C7B08CA8B392}" dt="2026-05-03T19:49:56.778" v="40" actId="1035"/>
+        <pc:sldMkLst>
+          <pc:docMk/>
+          <pc:sldMk cId="3232636054" sldId="724"/>
+        </pc:sldMkLst>
+        <pc:picChg chg="add del mod ord">
+          <ac:chgData name="Gerth Stølting Brodal" userId="04ef4784-6591-4f86-a140-f5c3b108582a" providerId="ADAL" clId="{73BAC7D6-516A-44B5-B4B0-C7B08CA8B392}" dt="2026-05-03T19:47:07.313" v="34" actId="167"/>
+          <ac:picMkLst>
+            <pc:docMk/>
+            <pc:sldMk cId="3232636054" sldId="724"/>
+            <ac:picMk id="3" creationId="{19C8794E-A018-4433-B6EB-3B14B3ABBA1D}"/>
+          </ac:picMkLst>
+        </pc:picChg>
+        <pc:picChg chg="mod ord">
+          <ac:chgData name="Gerth Stølting Brodal" userId="04ef4784-6591-4f86-a140-f5c3b108582a" providerId="ADAL" clId="{73BAC7D6-516A-44B5-B4B0-C7B08CA8B392}" dt="2026-05-03T19:47:30.488" v="37" actId="167"/>
+          <ac:picMkLst>
+            <pc:docMk/>
+            <pc:sldMk cId="3232636054" sldId="724"/>
+            <ac:picMk id="4" creationId="{00000000-0000-0000-0000-000000000000}"/>
+          </ac:picMkLst>
+        </pc:picChg>
+        <pc:picChg chg="add del">
+          <ac:chgData name="Gerth Stølting Brodal" userId="04ef4784-6591-4f86-a140-f5c3b108582a" providerId="ADAL" clId="{73BAC7D6-516A-44B5-B4B0-C7B08CA8B392}" dt="2026-05-03T19:43:47.751" v="7" actId="22"/>
+          <ac:picMkLst>
+            <pc:docMk/>
+            <pc:sldMk cId="3232636054" sldId="724"/>
+            <ac:picMk id="6" creationId="{DE037D80-6953-FA08-CA84-20426A9A0877}"/>
+          </ac:picMkLst>
+        </pc:picChg>
+        <pc:picChg chg="add del mod ord modCrop">
+          <ac:chgData name="Gerth Stølting Brodal" userId="04ef4784-6591-4f86-a140-f5c3b108582a" providerId="ADAL" clId="{73BAC7D6-516A-44B5-B4B0-C7B08CA8B392}" dt="2026-05-03T19:46:10.357" v="30" actId="478"/>
+          <ac:picMkLst>
+            <pc:docMk/>
+            <pc:sldMk cId="3232636054" sldId="724"/>
+            <ac:picMk id="8" creationId="{57762077-75C9-585C-C090-61937A81CDC6}"/>
+          </ac:picMkLst>
+        </pc:picChg>
+        <pc:picChg chg="add mod ord">
+          <ac:chgData name="Gerth Stølting Brodal" userId="04ef4784-6591-4f86-a140-f5c3b108582a" providerId="ADAL" clId="{73BAC7D6-516A-44B5-B4B0-C7B08CA8B392}" dt="2026-05-03T19:49:56.778" v="40" actId="1035"/>
+          <ac:picMkLst>
+            <pc:docMk/>
+            <pc:sldMk cId="3232636054" sldId="724"/>
+            <ac:picMk id="10" creationId="{3D55E4ED-F300-A147-432D-3733BD3DC8FE}"/>
+          </ac:picMkLst>
+        </pc:picChg>
+      </pc:sldChg>
+      <pc:sldChg chg="modNotesTx">
+        <pc:chgData name="Gerth Stølting Brodal" userId="04ef4784-6591-4f86-a140-f5c3b108582a" providerId="ADAL" clId="{73BAC7D6-516A-44B5-B4B0-C7B08CA8B392}" dt="2026-05-03T20:29:50.314" v="54" actId="20577"/>
+        <pc:sldMkLst>
+          <pc:docMk/>
+          <pc:sldMk cId="1890479042" sldId="725"/>
+        </pc:sldMkLst>
+      </pc:sldChg>
+      <pc:sldChg chg="addSp delSp modSp mod">
+        <pc:chgData name="Gerth Stølting Brodal" userId="04ef4784-6591-4f86-a140-f5c3b108582a" providerId="ADAL" clId="{73BAC7D6-516A-44B5-B4B0-C7B08CA8B392}" dt="2026-05-03T20:40:48.374" v="78" actId="478"/>
+        <pc:sldMkLst>
+          <pc:docMk/>
+          <pc:sldMk cId="3170264930" sldId="732"/>
+        </pc:sldMkLst>
+        <pc:spChg chg="del mod">
+          <ac:chgData name="Gerth Stølting Brodal" userId="04ef4784-6591-4f86-a140-f5c3b108582a" providerId="ADAL" clId="{73BAC7D6-516A-44B5-B4B0-C7B08CA8B392}" dt="2026-05-03T20:40:44.198" v="77" actId="478"/>
+          <ac:spMkLst>
+            <pc:docMk/>
+            <pc:sldMk cId="3170264930" sldId="732"/>
+            <ac:spMk id="2" creationId="{00000000-0000-0000-0000-000000000000}"/>
+          </ac:spMkLst>
+        </pc:spChg>
+        <pc:spChg chg="del mod">
+          <ac:chgData name="Gerth Stølting Brodal" userId="04ef4784-6591-4f86-a140-f5c3b108582a" providerId="ADAL" clId="{73BAC7D6-516A-44B5-B4B0-C7B08CA8B392}" dt="2026-05-03T20:40:37.968" v="75" actId="478"/>
+          <ac:spMkLst>
+            <pc:docMk/>
+            <pc:sldMk cId="3170264930" sldId="732"/>
+            <ac:spMk id="3" creationId="{00000000-0000-0000-0000-000000000000}"/>
+          </ac:spMkLst>
+        </pc:spChg>
+        <pc:spChg chg="add del mod">
+          <ac:chgData name="Gerth Stølting Brodal" userId="04ef4784-6591-4f86-a140-f5c3b108582a" providerId="ADAL" clId="{73BAC7D6-516A-44B5-B4B0-C7B08CA8B392}" dt="2026-05-03T20:40:48.374" v="78" actId="478"/>
+          <ac:spMkLst>
+            <pc:docMk/>
+            <pc:sldMk cId="3170264930" sldId="732"/>
+            <ac:spMk id="8" creationId="{1DF30F7A-424B-2EB6-794D-BBA33D5476F5}"/>
+          </ac:spMkLst>
+        </pc:spChg>
+        <pc:graphicFrameChg chg="mod modGraphic">
+          <ac:chgData name="Gerth Stølting Brodal" userId="04ef4784-6591-4f86-a140-f5c3b108582a" providerId="ADAL" clId="{73BAC7D6-516A-44B5-B4B0-C7B08CA8B392}" dt="2026-05-03T20:40:33.758" v="74" actId="1035"/>
+          <ac:graphicFrameMkLst>
+            <pc:docMk/>
+            <pc:sldMk cId="3170264930" sldId="732"/>
+            <ac:graphicFrameMk id="4" creationId="{00000000-0000-0000-0000-000000000000}"/>
+          </ac:graphicFrameMkLst>
+        </pc:graphicFrameChg>
+        <pc:picChg chg="mod">
+          <ac:chgData name="Gerth Stølting Brodal" userId="04ef4784-6591-4f86-a140-f5c3b108582a" providerId="ADAL" clId="{73BAC7D6-516A-44B5-B4B0-C7B08CA8B392}" dt="2026-05-03T20:40:33.758" v="74" actId="1035"/>
+          <ac:picMkLst>
+            <pc:docMk/>
+            <pc:sldMk cId="3170264930" sldId="732"/>
+            <ac:picMk id="5" creationId="{00000000-0000-0000-0000-000000000000}"/>
+          </ac:picMkLst>
+        </pc:picChg>
+        <pc:picChg chg="mod">
+          <ac:chgData name="Gerth Stølting Brodal" userId="04ef4784-6591-4f86-a140-f5c3b108582a" providerId="ADAL" clId="{73BAC7D6-516A-44B5-B4B0-C7B08CA8B392}" dt="2026-05-03T20:40:33.758" v="74" actId="1035"/>
+          <ac:picMkLst>
+            <pc:docMk/>
+            <pc:sldMk cId="3170264930" sldId="732"/>
+            <ac:picMk id="6" creationId="{00000000-0000-0000-0000-000000000000}"/>
+          </ac:picMkLst>
+        </pc:picChg>
+      </pc:sldChg>
+      <pc:sldChg chg="modNotesTx">
+        <pc:chgData name="Gerth Stølting Brodal" userId="04ef4784-6591-4f86-a140-f5c3b108582a" providerId="ADAL" clId="{73BAC7D6-516A-44B5-B4B0-C7B08CA8B392}" dt="2026-05-03T19:59:08.210" v="51" actId="20577"/>
         <pc:sldMkLst>
           <pc:docMk/>
           <pc:sldMk cId="3428786955" sldId="733"/>
         </pc:sldMkLst>
-        <pc:graphicFrameChg chg="modGraphic">
-          <ac:chgData name="Gerth Stølting Brodal" userId="04ef4784-6591-4f86-a140-f5c3b108582a" providerId="ADAL" clId="{73BAC7D6-516A-44B5-B4B0-C7B08CA8B392}" dt="2026-03-18T13:07:10.753" v="5" actId="20577"/>
-          <ac:graphicFrameMkLst>
-            <pc:docMk/>
-            <pc:sldMk cId="3428786955" sldId="733"/>
-            <ac:graphicFrameMk id="4" creationId="{00000000-0000-0000-0000-000000000000}"/>
-          </ac:graphicFrameMkLst>
-        </pc:graphicFrameChg>
       </pc:sldChg>
     </pc:docChg>
   </pc:docChgLst>
@@ -245,7 +369,7 @@
           <a:p>
             <a:fld id="{FB1A172F-81D4-4DC4-9113-1DBD56EC3646}" type="datetimeFigureOut">
               <a:rPr lang="en-US" smtClean="0"/>
-              <a:t>3/18/2026</a:t>
+              <a:t>5/3/2026</a:t>
             </a:fld>
             <a:endParaRPr lang="en-US"/>
           </a:p>
@@ -646,6 +770,98 @@
           <a:p>
             <a:r>
               <a:rPr lang="en-US" dirty="0"/>
+              <a:t>Keys are bound to the root window, whereas mouse clicks are bound to the specific widget</a:t>
+            </a:r>
+            <a:r>
+              <a:rPr lang="en-US"/>
+              <a:t>(=canvas)</a:t>
+            </a:r>
+            <a:endParaRPr lang="en-US" dirty="0"/>
+          </a:p>
+        </p:txBody>
+      </p:sp>
+      <p:sp>
+        <p:nvSpPr>
+          <p:cNvPr id="4" name="Slide Number Placeholder 3"/>
+          <p:cNvSpPr>
+            <a:spLocks noGrp="1"/>
+          </p:cNvSpPr>
+          <p:nvPr>
+            <p:ph type="sldNum" sz="quarter" idx="10"/>
+          </p:nvPr>
+        </p:nvSpPr>
+        <p:spPr/>
+        <p:txBody>
+          <a:bodyPr/>
+          <a:lstStyle/>
+          <a:p>
+            <a:fld id="{CD563DD8-32AB-41BE-B1C6-8EAC45222ACE}" type="slidenum">
+              <a:rPr lang="en-US" smtClean="0"/>
+              <a:t>18</a:t>
+            </a:fld>
+            <a:endParaRPr lang="en-US"/>
+          </a:p>
+        </p:txBody>
+      </p:sp>
+    </p:spTree>
+    <p:extLst>
+      <p:ext uri="{BB962C8B-B14F-4D97-AF65-F5344CB8AC3E}">
+        <p14:creationId xmlns:p14="http://schemas.microsoft.com/office/powerpoint/2010/main" val="170041126"/>
+      </p:ext>
+    </p:extLst>
+  </p:cSld>
+  <p:clrMapOvr>
+    <a:masterClrMapping/>
+  </p:clrMapOvr>
+</p:notes>
+</file>
+
+<file path=ppt/notesSlides/notesSlide11.xml><?xml version="1.0" encoding="utf-8"?>
+<p:notes xmlns:a="http://schemas.openxmlformats.org/drawingml/2006/main" xmlns:r="http://schemas.openxmlformats.org/officeDocument/2006/relationships" xmlns:p="http://schemas.openxmlformats.org/presentationml/2006/main">
+  <p:cSld>
+    <p:spTree>
+      <p:nvGrpSpPr>
+        <p:cNvPr id="1" name=""/>
+        <p:cNvGrpSpPr/>
+        <p:nvPr/>
+      </p:nvGrpSpPr>
+      <p:grpSpPr>
+        <a:xfrm>
+          <a:off x="0" y="0"/>
+          <a:ext cx="0" cy="0"/>
+          <a:chOff x="0" y="0"/>
+          <a:chExt cx="0" cy="0"/>
+        </a:xfrm>
+      </p:grpSpPr>
+      <p:sp>
+        <p:nvSpPr>
+          <p:cNvPr id="2" name="Slide Image Placeholder 1"/>
+          <p:cNvSpPr>
+            <a:spLocks noGrp="1" noRot="1" noChangeAspect="1"/>
+          </p:cNvSpPr>
+          <p:nvPr>
+            <p:ph type="sldImg"/>
+          </p:nvPr>
+        </p:nvSpPr>
+        <p:spPr/>
+      </p:sp>
+      <p:sp>
+        <p:nvSpPr>
+          <p:cNvPr id="3" name="Notes Placeholder 2"/>
+          <p:cNvSpPr>
+            <a:spLocks noGrp="1"/>
+          </p:cNvSpPr>
+          <p:nvPr>
+            <p:ph type="body" idx="1"/>
+          </p:nvPr>
+        </p:nvSpPr>
+        <p:spPr/>
+        <p:txBody>
+          <a:bodyPr/>
+          <a:lstStyle/>
+          <a:p>
+            <a:r>
+              <a:rPr lang="en-US" dirty="0"/>
               <a:t>Grid : top-row 2 buttons + </a:t>
             </a:r>
             <a:r>
@@ -868,6 +1084,114 @@
           <a:lstStyle/>
           <a:p>
             <a:r>
+              <a:rPr lang="en-US" sz="1200" b="0" u="none" strike="noStrike" kern="1200" dirty="0">
+                <a:solidFill>
+                  <a:schemeClr val="tx1"/>
+                </a:solidFill>
+                <a:effectLst/>
+                <a:latin typeface="+mn-lt"/>
+                <a:ea typeface="+mn-ea"/>
+                <a:cs typeface="+mn-cs"/>
+              </a:rPr>
+              <a:t>pronounced </a:t>
+            </a:r>
+            <a:r>
+              <a:rPr lang="en-US" sz="1200" b="1" u="none" strike="noStrike" kern="1200" dirty="0">
+                <a:solidFill>
+                  <a:schemeClr val="tx1"/>
+                </a:solidFill>
+                <a:effectLst/>
+                <a:latin typeface="+mn-lt"/>
+                <a:ea typeface="+mn-ea"/>
+                <a:cs typeface="+mn-cs"/>
+              </a:rPr>
+              <a:t>"tickle tee-kay"</a:t>
+            </a:r>
+            <a:endParaRPr lang="en-US" dirty="0"/>
+          </a:p>
+        </p:txBody>
+      </p:sp>
+      <p:sp>
+        <p:nvSpPr>
+          <p:cNvPr id="4" name="Slide Number Placeholder 3"/>
+          <p:cNvSpPr>
+            <a:spLocks noGrp="1"/>
+          </p:cNvSpPr>
+          <p:nvPr>
+            <p:ph type="sldNum" sz="quarter" idx="5"/>
+          </p:nvPr>
+        </p:nvSpPr>
+        <p:spPr/>
+        <p:txBody>
+          <a:bodyPr/>
+          <a:lstStyle/>
+          <a:p>
+            <a:fld id="{CD563DD8-32AB-41BE-B1C6-8EAC45222ACE}" type="slidenum">
+              <a:rPr lang="en-US" smtClean="0"/>
+              <a:t>6</a:t>
+            </a:fld>
+            <a:endParaRPr lang="en-US"/>
+          </a:p>
+        </p:txBody>
+      </p:sp>
+    </p:spTree>
+    <p:extLst>
+      <p:ext uri="{BB962C8B-B14F-4D97-AF65-F5344CB8AC3E}">
+        <p14:creationId xmlns:p14="http://schemas.microsoft.com/office/powerpoint/2010/main" val="3451876099"/>
+      </p:ext>
+    </p:extLst>
+  </p:cSld>
+  <p:clrMapOvr>
+    <a:masterClrMapping/>
+  </p:clrMapOvr>
+</p:notes>
+</file>
+
+<file path=ppt/notesSlides/notesSlide4.xml><?xml version="1.0" encoding="utf-8"?>
+<p:notes xmlns:a="http://schemas.openxmlformats.org/drawingml/2006/main" xmlns:r="http://schemas.openxmlformats.org/officeDocument/2006/relationships" xmlns:p="http://schemas.openxmlformats.org/presentationml/2006/main">
+  <p:cSld>
+    <p:spTree>
+      <p:nvGrpSpPr>
+        <p:cNvPr id="1" name=""/>
+        <p:cNvGrpSpPr/>
+        <p:nvPr/>
+      </p:nvGrpSpPr>
+      <p:grpSpPr>
+        <a:xfrm>
+          <a:off x="0" y="0"/>
+          <a:ext cx="0" cy="0"/>
+          <a:chOff x="0" y="0"/>
+          <a:chExt cx="0" cy="0"/>
+        </a:xfrm>
+      </p:grpSpPr>
+      <p:sp>
+        <p:nvSpPr>
+          <p:cNvPr id="2" name="Slide Image Placeholder 1"/>
+          <p:cNvSpPr>
+            <a:spLocks noGrp="1" noRot="1" noChangeAspect="1"/>
+          </p:cNvSpPr>
+          <p:nvPr>
+            <p:ph type="sldImg"/>
+          </p:nvPr>
+        </p:nvSpPr>
+        <p:spPr/>
+      </p:sp>
+      <p:sp>
+        <p:nvSpPr>
+          <p:cNvPr id="3" name="Notes Placeholder 2"/>
+          <p:cNvSpPr>
+            <a:spLocks noGrp="1"/>
+          </p:cNvSpPr>
+          <p:nvPr>
+            <p:ph type="body" idx="1"/>
+          </p:nvPr>
+        </p:nvSpPr>
+        <p:spPr/>
+        <p:txBody>
+          <a:bodyPr/>
+          <a:lstStyle/>
+          <a:p>
+            <a:r>
               <a:rPr lang="da-DK" dirty="0" err="1"/>
               <a:t>place</a:t>
             </a:r>
@@ -942,7 +1266,7 @@
 </p:notes>
 </file>
 
-<file path=ppt/notesSlides/notesSlide4.xml><?xml version="1.0" encoding="utf-8"?>
+<file path=ppt/notesSlides/notesSlide5.xml><?xml version="1.0" encoding="utf-8"?>
 <p:notes xmlns:a="http://schemas.openxmlformats.org/drawingml/2006/main" xmlns:r="http://schemas.openxmlformats.org/officeDocument/2006/relationships" xmlns:p="http://schemas.openxmlformats.org/presentationml/2006/main">
   <p:cSld>
     <p:spTree>
@@ -1026,127 +1350,6 @@
 </p:notes>
 </file>
 
-<file path=ppt/notesSlides/notesSlide5.xml><?xml version="1.0" encoding="utf-8"?>
-<p:notes xmlns:a="http://schemas.openxmlformats.org/drawingml/2006/main" xmlns:r="http://schemas.openxmlformats.org/officeDocument/2006/relationships" xmlns:p="http://schemas.openxmlformats.org/presentationml/2006/main">
-  <p:cSld>
-    <p:spTree>
-      <p:nvGrpSpPr>
-        <p:cNvPr id="1" name=""/>
-        <p:cNvGrpSpPr/>
-        <p:nvPr/>
-      </p:nvGrpSpPr>
-      <p:grpSpPr>
-        <a:xfrm>
-          <a:off x="0" y="0"/>
-          <a:ext cx="0" cy="0"/>
-          <a:chOff x="0" y="0"/>
-          <a:chExt cx="0" cy="0"/>
-        </a:xfrm>
-      </p:grpSpPr>
-      <p:sp>
-        <p:nvSpPr>
-          <p:cNvPr id="2" name="Slide Image Placeholder 1"/>
-          <p:cNvSpPr>
-            <a:spLocks noGrp="1" noRot="1" noChangeAspect="1"/>
-          </p:cNvSpPr>
-          <p:nvPr>
-            <p:ph type="sldImg"/>
-          </p:nvPr>
-        </p:nvSpPr>
-        <p:spPr/>
-      </p:sp>
-      <p:sp>
-        <p:nvSpPr>
-          <p:cNvPr id="3" name="Notes Placeholder 2"/>
-          <p:cNvSpPr>
-            <a:spLocks noGrp="1"/>
-          </p:cNvSpPr>
-          <p:nvPr>
-            <p:ph type="body" idx="1"/>
-          </p:nvPr>
-        </p:nvSpPr>
-        <p:spPr/>
-        <p:txBody>
-          <a:bodyPr/>
-          <a:lstStyle/>
-          <a:p>
-            <a:r>
-              <a:rPr lang="en-US" dirty="0"/>
-              <a:t>inversion of control</a:t>
-            </a:r>
-          </a:p>
-          <a:p>
-            <a:endParaRPr lang="en-US" dirty="0"/>
-          </a:p>
-          <a:p>
-            <a:r>
-              <a:rPr lang="en-US" dirty="0" err="1"/>
-              <a:t>mainloop</a:t>
-            </a:r>
-            <a:r>
-              <a:rPr lang="en-US" dirty="0"/>
-              <a:t>  # without this,</a:t>
-            </a:r>
-            <a:r>
-              <a:rPr lang="en-US" baseline="0" dirty="0"/>
-              <a:t> the </a:t>
-            </a:r>
-            <a:r>
-              <a:rPr lang="en-US" baseline="0"/>
-              <a:t>window will </a:t>
-            </a:r>
-            <a:r>
-              <a:rPr lang="en-US" baseline="0" dirty="0"/>
-              <a:t>show up but </a:t>
-            </a:r>
-            <a:r>
-              <a:rPr lang="en-US" baseline="0"/>
-              <a:t>program terminates </a:t>
-            </a:r>
-            <a:r>
-              <a:rPr lang="en-US" baseline="0" dirty="0"/>
-              <a:t>if run from shell</a:t>
-            </a:r>
-            <a:endParaRPr lang="en-US" dirty="0"/>
-          </a:p>
-        </p:txBody>
-      </p:sp>
-      <p:sp>
-        <p:nvSpPr>
-          <p:cNvPr id="4" name="Slide Number Placeholder 3"/>
-          <p:cNvSpPr>
-            <a:spLocks noGrp="1"/>
-          </p:cNvSpPr>
-          <p:nvPr>
-            <p:ph type="sldNum" sz="quarter" idx="10"/>
-          </p:nvPr>
-        </p:nvSpPr>
-        <p:spPr/>
-        <p:txBody>
-          <a:bodyPr/>
-          <a:lstStyle/>
-          <a:p>
-            <a:fld id="{CD563DD8-32AB-41BE-B1C6-8EAC45222ACE}" type="slidenum">
-              <a:rPr lang="en-US" smtClean="0"/>
-              <a:t>9</a:t>
-            </a:fld>
-            <a:endParaRPr lang="en-US"/>
-          </a:p>
-        </p:txBody>
-      </p:sp>
-    </p:spTree>
-    <p:extLst>
-      <p:ext uri="{BB962C8B-B14F-4D97-AF65-F5344CB8AC3E}">
-        <p14:creationId xmlns:p14="http://schemas.microsoft.com/office/powerpoint/2010/main" val="3750928809"/>
-      </p:ext>
-    </p:extLst>
-  </p:cSld>
-  <p:clrMapOvr>
-    <a:masterClrMapping/>
-  </p:clrMapOvr>
-</p:notes>
-</file>
-
 <file path=ppt/notesSlides/notesSlide6.xml><?xml version="1.0" encoding="utf-8"?>
 <p:notes xmlns:a="http://schemas.openxmlformats.org/drawingml/2006/main" xmlns:r="http://schemas.openxmlformats.org/officeDocument/2006/relationships" xmlns:p="http://schemas.openxmlformats.org/presentationml/2006/main">
   <p:cSld>
@@ -1192,14 +1395,24 @@
           <a:lstStyle/>
           <a:p>
             <a:r>
-              <a:rPr lang="da-DK" dirty="0"/>
-              <a:t>(0,0) = upper </a:t>
-            </a:r>
-            <a:r>
-              <a:rPr lang="da-DK" dirty="0" err="1"/>
-              <a:t>left</a:t>
-            </a:r>
-            <a:endParaRPr lang="da-DK" dirty="0"/>
+              <a:rPr lang="en-US" b="1" dirty="0"/>
+              <a:t>&amp;inversion of control</a:t>
+            </a:r>
+          </a:p>
+          <a:p>
+            <a:r>
+              <a:rPr lang="en-US" dirty="0" err="1"/>
+              <a:t>mainloop</a:t>
+            </a:r>
+            <a:r>
+              <a:rPr lang="en-US" dirty="0"/>
+              <a:t>  # without this,</a:t>
+            </a:r>
+            <a:r>
+              <a:rPr lang="en-US" baseline="0" dirty="0"/>
+              <a:t> the window will show up but program terminates if run from shell</a:t>
+            </a:r>
+            <a:endParaRPr lang="en-US" dirty="0"/>
           </a:p>
         </p:txBody>
       </p:sp>
@@ -1210,7 +1423,7 @@
             <a:spLocks noGrp="1"/>
           </p:cNvSpPr>
           <p:nvPr>
-            <p:ph type="sldNum" sz="quarter" idx="5"/>
+            <p:ph type="sldNum" sz="quarter" idx="10"/>
           </p:nvPr>
         </p:nvSpPr>
         <p:spPr/>
@@ -1220,7 +1433,7 @@
           <a:p>
             <a:fld id="{CD563DD8-32AB-41BE-B1C6-8EAC45222ACE}" type="slidenum">
               <a:rPr lang="en-US" smtClean="0"/>
-              <a:t>13</a:t>
+              <a:t>9</a:t>
             </a:fld>
             <a:endParaRPr lang="en-US"/>
           </a:p>
@@ -1229,7 +1442,7 @@
     </p:spTree>
     <p:extLst>
       <p:ext uri="{BB962C8B-B14F-4D97-AF65-F5344CB8AC3E}">
-        <p14:creationId xmlns:p14="http://schemas.microsoft.com/office/powerpoint/2010/main" val="4183965177"/>
+        <p14:creationId xmlns:p14="http://schemas.microsoft.com/office/powerpoint/2010/main" val="3750928809"/>
       </p:ext>
     </p:extLst>
   </p:cSld>
@@ -1284,171 +1497,14 @@
           <a:lstStyle/>
           <a:p>
             <a:r>
+              <a:rPr lang="da-DK" dirty="0"/>
+              <a:t>(0,0) = upper </a:t>
+            </a:r>
+            <a:r>
               <a:rPr lang="da-DK" dirty="0" err="1"/>
-              <a:t>Qt</a:t>
-            </a:r>
-            <a:r>
-              <a:rPr lang="da-DK" baseline="0" dirty="0"/>
-              <a:t> more </a:t>
-            </a:r>
-            <a:r>
-              <a:rPr lang="da-DK" baseline="0" dirty="0" err="1"/>
-              <a:t>modern</a:t>
-            </a:r>
-            <a:r>
-              <a:rPr lang="da-DK" baseline="0" dirty="0"/>
-              <a:t> </a:t>
-            </a:r>
-            <a:r>
-              <a:rPr lang="da-DK" baseline="0" dirty="0" err="1"/>
-              <a:t>framework</a:t>
-            </a:r>
-            <a:r>
-              <a:rPr lang="da-DK" baseline="0" dirty="0"/>
-              <a:t> (</a:t>
-            </a:r>
-            <a:r>
-              <a:rPr lang="da-DK" baseline="0" dirty="0" err="1"/>
-              <a:t>written</a:t>
-            </a:r>
-            <a:r>
-              <a:rPr lang="da-DK" baseline="0" dirty="0"/>
-              <a:t> in C++)</a:t>
-            </a:r>
-          </a:p>
-          <a:p>
-            <a:r>
-              <a:rPr lang="da-DK" baseline="0" dirty="0"/>
-              <a:t>Can </a:t>
-            </a:r>
-            <a:r>
-              <a:rPr lang="da-DK" baseline="0" dirty="0" err="1"/>
-              <a:t>use</a:t>
-            </a:r>
-            <a:r>
-              <a:rPr lang="da-DK" baseline="0" dirty="0"/>
-              <a:t> </a:t>
-            </a:r>
-            <a:r>
-              <a:rPr lang="da-DK" baseline="0" dirty="0" err="1"/>
-              <a:t>QtDesigner</a:t>
-            </a:r>
-            <a:r>
-              <a:rPr lang="da-DK" baseline="0" dirty="0"/>
-              <a:t> to design interfaces</a:t>
-            </a:r>
-          </a:p>
-          <a:p>
-            <a:endParaRPr lang="da-DK" baseline="0" dirty="0"/>
-          </a:p>
-          <a:p>
-            <a:r>
-              <a:rPr lang="da-DK" baseline="0" dirty="0" err="1"/>
-              <a:t>tkinter.messagebox.showinfo</a:t>
-            </a:r>
-            <a:r>
-              <a:rPr lang="da-DK" baseline="0" dirty="0"/>
-              <a:t>  </a:t>
-            </a:r>
-            <a:r>
-              <a:rPr lang="da-DK" baseline="0" dirty="0" err="1"/>
-              <a:t>requires</a:t>
-            </a:r>
-            <a:r>
-              <a:rPr lang="da-DK" baseline="0" dirty="0"/>
-              <a:t> ”import </a:t>
-            </a:r>
-            <a:r>
-              <a:rPr lang="da-DK" baseline="0" dirty="0" err="1"/>
-              <a:t>tkinter.messagebox</a:t>
-            </a:r>
-            <a:r>
-              <a:rPr lang="da-DK" baseline="0" dirty="0"/>
-              <a:t>”, </a:t>
-            </a:r>
-            <a:r>
-              <a:rPr lang="da-DK" baseline="0" dirty="0" err="1"/>
-              <a:t>other</a:t>
-            </a:r>
-            <a:r>
-              <a:rPr lang="da-DK" baseline="0" dirty="0"/>
-              <a:t> </a:t>
-            </a:r>
-            <a:r>
-              <a:rPr lang="da-DK" baseline="0" dirty="0" err="1"/>
-              <a:t>fails</a:t>
-            </a:r>
-            <a:r>
-              <a:rPr lang="da-DK" baseline="0" dirty="0"/>
-              <a:t> with ”</a:t>
-            </a:r>
-            <a:r>
-              <a:rPr lang="en-US" baseline="0" dirty="0"/>
-              <a:t>module '</a:t>
-            </a:r>
-            <a:r>
-              <a:rPr lang="en-US" baseline="0" dirty="0" err="1"/>
-              <a:t>tkinter</a:t>
-            </a:r>
-            <a:r>
-              <a:rPr lang="en-US" baseline="0" dirty="0"/>
-              <a:t>' has no attribute '</a:t>
-            </a:r>
-            <a:r>
-              <a:rPr lang="en-US" baseline="0" dirty="0" err="1"/>
-              <a:t>messagebox</a:t>
-            </a:r>
-            <a:r>
-              <a:rPr lang="en-US" baseline="0" dirty="0"/>
-              <a:t>’” since submodule</a:t>
-            </a:r>
-          </a:p>
-          <a:p>
-            <a:r>
-              <a:rPr lang="en-US" baseline="0" dirty="0"/>
-              <a:t>.</a:t>
-            </a:r>
-            <a:r>
-              <a:rPr lang="en-US" baseline="0" dirty="0" err="1"/>
-              <a:t>resizeable</a:t>
-            </a:r>
-            <a:r>
-              <a:rPr lang="en-US" baseline="0" dirty="0"/>
-              <a:t>(False, False) or .</a:t>
-            </a:r>
-            <a:r>
-              <a:rPr lang="en-US" baseline="0" dirty="0" err="1"/>
-              <a:t>resizeable</a:t>
-            </a:r>
-            <a:r>
-              <a:rPr lang="en-US" baseline="0" dirty="0"/>
-              <a:t>(0, 0) disables </a:t>
-            </a:r>
-            <a:r>
-              <a:rPr lang="en-US" baseline="0" dirty="0" err="1"/>
-              <a:t>resizeable</a:t>
-            </a:r>
-            <a:r>
-              <a:rPr lang="en-US" baseline="0" dirty="0"/>
-              <a:t> and “</a:t>
-            </a:r>
-            <a:r>
-              <a:rPr lang="en-US" baseline="0" dirty="0" err="1"/>
-              <a:t>fullscreen</a:t>
-            </a:r>
-            <a:r>
-              <a:rPr lang="en-US" baseline="0" dirty="0"/>
-              <a:t>” button on the window’s </a:t>
-            </a:r>
-            <a:r>
-              <a:rPr lang="en-US" baseline="0" dirty="0" err="1"/>
-              <a:t>topbar</a:t>
-            </a:r>
-            <a:r>
-              <a:rPr lang="en-US" baseline="0" dirty="0"/>
-              <a:t>.</a:t>
-            </a:r>
-            <a:endParaRPr lang="en-US" dirty="0"/>
+              <a:t>left</a:t>
+            </a:r>
+            <a:endParaRPr lang="da-DK" dirty="0"/>
           </a:p>
         </p:txBody>
       </p:sp>
@@ -1459,7 +1515,7 @@
             <a:spLocks noGrp="1"/>
           </p:cNvSpPr>
           <p:nvPr>
-            <p:ph type="sldNum" sz="quarter" idx="10"/>
+            <p:ph type="sldNum" sz="quarter" idx="5"/>
           </p:nvPr>
         </p:nvSpPr>
         <p:spPr/>
@@ -1469,7 +1525,7 @@
           <a:p>
             <a:fld id="{CD563DD8-32AB-41BE-B1C6-8EAC45222ACE}" type="slidenum">
               <a:rPr lang="en-US" smtClean="0"/>
-              <a:t>16</a:t>
+              <a:t>13</a:t>
             </a:fld>
             <a:endParaRPr lang="en-US"/>
           </a:p>
@@ -1478,7 +1534,7 @@
     </p:spTree>
     <p:extLst>
       <p:ext uri="{BB962C8B-B14F-4D97-AF65-F5344CB8AC3E}">
-        <p14:creationId xmlns:p14="http://schemas.microsoft.com/office/powerpoint/2010/main" val="2458497683"/>
+        <p14:creationId xmlns:p14="http://schemas.microsoft.com/office/powerpoint/2010/main" val="4183965177"/>
       </p:ext>
     </p:extLst>
   </p:cSld>
@@ -1533,18 +1589,111 @@
           <a:lstStyle/>
           <a:p>
             <a:r>
-              <a:rPr lang="en-US" dirty="0"/>
-              <a:t>Use </a:t>
-            </a:r>
-            <a:r>
-              <a:rPr lang="en-US" dirty="0" err="1"/>
-              <a:t>root.config</a:t>
-            </a:r>
-            <a:r>
-              <a:rPr lang="en-US" dirty="0"/>
-              <a:t> to show menu instead of .pack or .grid</a:t>
-            </a:r>
-            <a:endParaRPr lang="da-DK" dirty="0"/>
+              <a:rPr lang="en-US" noProof="0" dirty="0"/>
+              <a:t>Qt</a:t>
+            </a:r>
+            <a:r>
+              <a:rPr lang="en-US" baseline="0" noProof="0" dirty="0"/>
+              <a:t> more modern framework (written in C++)</a:t>
+            </a:r>
+          </a:p>
+          <a:p>
+            <a:r>
+              <a:rPr lang="en-US" baseline="0" noProof="0" dirty="0"/>
+              <a:t>Can use </a:t>
+            </a:r>
+            <a:r>
+              <a:rPr lang="en-US" baseline="0" noProof="0" dirty="0" err="1"/>
+              <a:t>QtDesigner</a:t>
+            </a:r>
+            <a:r>
+              <a:rPr lang="en-US" baseline="0" noProof="0" dirty="0"/>
+              <a:t> to design interfaces</a:t>
+            </a:r>
+          </a:p>
+          <a:p>
+            <a:endParaRPr lang="en-US" baseline="0" noProof="0" dirty="0"/>
+          </a:p>
+          <a:p>
+            <a:r>
+              <a:rPr lang="en-US" baseline="0" noProof="0" dirty="0" err="1"/>
+              <a:t>tkinter.messagebox.showinfo</a:t>
+            </a:r>
+            <a:r>
+              <a:rPr lang="en-US" baseline="0" noProof="0" dirty="0"/>
+              <a:t>  requires ”import </a:t>
+            </a:r>
+            <a:r>
+              <a:rPr lang="en-US" baseline="0" noProof="0" dirty="0" err="1"/>
+              <a:t>tkinter.messagebox</a:t>
+            </a:r>
+            <a:r>
+              <a:rPr lang="en-US" baseline="0" noProof="0" dirty="0"/>
+              <a:t>”, otherwise fails with ”module '</a:t>
+            </a:r>
+            <a:r>
+              <a:rPr lang="en-US" baseline="0" noProof="0" dirty="0" err="1"/>
+              <a:t>tkinter</a:t>
+            </a:r>
+            <a:r>
+              <a:rPr lang="en-US" baseline="0" noProof="0" dirty="0"/>
+              <a:t>' has no attribute '</a:t>
+            </a:r>
+            <a:r>
+              <a:rPr lang="en-US" baseline="0" noProof="0" dirty="0" err="1"/>
+              <a:t>messagebox</a:t>
+            </a:r>
+            <a:r>
+              <a:rPr lang="en-US" baseline="0" noProof="0" dirty="0"/>
+              <a:t>’” since submodule</a:t>
+            </a:r>
+          </a:p>
+          <a:p>
+            <a:r>
+              <a:rPr lang="en-US" baseline="0" noProof="0" dirty="0"/>
+              <a:t>.</a:t>
+            </a:r>
+            <a:r>
+              <a:rPr lang="en-US" baseline="0" noProof="0" dirty="0" err="1"/>
+              <a:t>resizeable</a:t>
+            </a:r>
+            <a:r>
+              <a:rPr lang="en-US" baseline="0" noProof="0" dirty="0"/>
+              <a:t>(False, False) or .</a:t>
+            </a:r>
+            <a:r>
+              <a:rPr lang="en-US" baseline="0" noProof="0" dirty="0" err="1"/>
+              <a:t>resizeable</a:t>
+            </a:r>
+            <a:r>
+              <a:rPr lang="en-US" baseline="0" noProof="0" dirty="0"/>
+              <a:t>(0, 0) disables </a:t>
+            </a:r>
+            <a:r>
+              <a:rPr lang="en-US" baseline="0" noProof="0" dirty="0" err="1"/>
+              <a:t>resizeable</a:t>
+            </a:r>
+            <a:r>
+              <a:rPr lang="en-US" baseline="0" noProof="0" dirty="0"/>
+              <a:t> and “</a:t>
+            </a:r>
+            <a:r>
+              <a:rPr lang="en-US" baseline="0" noProof="0" dirty="0" err="1"/>
+              <a:t>fullscreen</a:t>
+            </a:r>
+            <a:r>
+              <a:rPr lang="en-US" baseline="0" noProof="0" dirty="0"/>
+              <a:t>” button on the window’s </a:t>
+            </a:r>
+            <a:r>
+              <a:rPr lang="en-US" baseline="0" noProof="0" dirty="0" err="1"/>
+              <a:t>topbar</a:t>
+            </a:r>
+            <a:r>
+              <a:rPr lang="en-US" baseline="0" noProof="0" dirty="0"/>
+              <a:t>.</a:t>
+            </a:r>
+            <a:endParaRPr lang="en-US" noProof="0" dirty="0"/>
           </a:p>
         </p:txBody>
       </p:sp>
@@ -1555,7 +1704,7 @@
             <a:spLocks noGrp="1"/>
           </p:cNvSpPr>
           <p:nvPr>
-            <p:ph type="sldNum" sz="quarter" idx="5"/>
+            <p:ph type="sldNum" sz="quarter" idx="10"/>
           </p:nvPr>
         </p:nvSpPr>
         <p:spPr/>
@@ -1565,7 +1714,7 @@
           <a:p>
             <a:fld id="{CD563DD8-32AB-41BE-B1C6-8EAC45222ACE}" type="slidenum">
               <a:rPr lang="en-US" smtClean="0"/>
-              <a:t>17</a:t>
+              <a:t>16</a:t>
             </a:fld>
             <a:endParaRPr lang="en-US"/>
           </a:p>
@@ -1574,7 +1723,7 @@
     </p:spTree>
     <p:extLst>
       <p:ext uri="{BB962C8B-B14F-4D97-AF65-F5344CB8AC3E}">
-        <p14:creationId xmlns:p14="http://schemas.microsoft.com/office/powerpoint/2010/main" val="3658298418"/>
+        <p14:creationId xmlns:p14="http://schemas.microsoft.com/office/powerpoint/2010/main" val="2458497683"/>
       </p:ext>
     </p:extLst>
   </p:cSld>
@@ -1630,13 +1779,17 @@
           <a:p>
             <a:r>
               <a:rPr lang="en-US" dirty="0"/>
-              <a:t>Keys are bound to the root window, whereas mouse clicks are bound to the specific widget</a:t>
-            </a:r>
-            <a:r>
-              <a:rPr lang="en-US"/>
-              <a:t>(=canvas)</a:t>
-            </a:r>
-            <a:endParaRPr lang="en-US" dirty="0"/>
+              <a:t>Use </a:t>
+            </a:r>
+            <a:r>
+              <a:rPr lang="en-US" dirty="0" err="1"/>
+              <a:t>root.config</a:t>
+            </a:r>
+            <a:r>
+              <a:rPr lang="en-US" dirty="0"/>
+              <a:t> to show menu instead of .pack or .grid</a:t>
+            </a:r>
+            <a:endParaRPr lang="da-DK" dirty="0"/>
           </a:p>
         </p:txBody>
       </p:sp>
@@ -1647,7 +1800,7 @@
             <a:spLocks noGrp="1"/>
           </p:cNvSpPr>
           <p:nvPr>
-            <p:ph type="sldNum" sz="quarter" idx="10"/>
+            <p:ph type="sldNum" sz="quarter" idx="5"/>
           </p:nvPr>
         </p:nvSpPr>
         <p:spPr/>
@@ -1657,7 +1810,7 @@
           <a:p>
             <a:fld id="{CD563DD8-32AB-41BE-B1C6-8EAC45222ACE}" type="slidenum">
               <a:rPr lang="en-US" smtClean="0"/>
-              <a:t>18</a:t>
+              <a:t>17</a:t>
             </a:fld>
             <a:endParaRPr lang="en-US"/>
           </a:p>
@@ -1666,7 +1819,7 @@
     </p:spTree>
     <p:extLst>
       <p:ext uri="{BB962C8B-B14F-4D97-AF65-F5344CB8AC3E}">
-        <p14:creationId xmlns:p14="http://schemas.microsoft.com/office/powerpoint/2010/main" val="170041126"/>
+        <p14:creationId xmlns:p14="http://schemas.microsoft.com/office/powerpoint/2010/main" val="3658298418"/>
       </p:ext>
     </p:extLst>
   </p:cSld>
@@ -1813,7 +1966,7 @@
           <a:p>
             <a:fld id="{0560A9CD-0304-4E0B-9E82-E7E0115DE05B}" type="datetimeFigureOut">
               <a:rPr lang="en-US" smtClean="0"/>
-              <a:t>3/18/2026</a:t>
+              <a:t>5/3/2026</a:t>
             </a:fld>
             <a:endParaRPr lang="en-US"/>
           </a:p>
@@ -1981,7 +2134,7 @@
           <a:p>
             <a:fld id="{0560A9CD-0304-4E0B-9E82-E7E0115DE05B}" type="datetimeFigureOut">
               <a:rPr lang="en-US" smtClean="0"/>
-              <a:t>3/18/2026</a:t>
+              <a:t>5/3/2026</a:t>
             </a:fld>
             <a:endParaRPr lang="en-US"/>
           </a:p>
@@ -2159,7 +2312,7 @@
           <a:p>
             <a:fld id="{0560A9CD-0304-4E0B-9E82-E7E0115DE05B}" type="datetimeFigureOut">
               <a:rPr lang="en-US" smtClean="0"/>
-              <a:t>3/18/2026</a:t>
+              <a:t>5/3/2026</a:t>
             </a:fld>
             <a:endParaRPr lang="en-US"/>
           </a:p>
@@ -2342,7 +2495,7 @@
           <a:p>
             <a:fld id="{0560A9CD-0304-4E0B-9E82-E7E0115DE05B}" type="datetimeFigureOut">
               <a:rPr lang="en-US" smtClean="0"/>
-              <a:t>3/18/2026</a:t>
+              <a:t>5/3/2026</a:t>
             </a:fld>
             <a:endParaRPr lang="en-US"/>
           </a:p>
@@ -2587,7 +2740,7 @@
           <a:p>
             <a:fld id="{0560A9CD-0304-4E0B-9E82-E7E0115DE05B}" type="datetimeFigureOut">
               <a:rPr lang="en-US" smtClean="0"/>
-              <a:t>3/18/2026</a:t>
+              <a:t>5/3/2026</a:t>
             </a:fld>
             <a:endParaRPr lang="en-US"/>
           </a:p>
@@ -2816,7 +2969,7 @@
           <a:p>
             <a:fld id="{0560A9CD-0304-4E0B-9E82-E7E0115DE05B}" type="datetimeFigureOut">
               <a:rPr lang="en-US" smtClean="0"/>
-              <a:t>3/18/2026</a:t>
+              <a:t>5/3/2026</a:t>
             </a:fld>
             <a:endParaRPr lang="en-US"/>
           </a:p>
@@ -3180,7 +3333,7 @@
           <a:p>
             <a:fld id="{0560A9CD-0304-4E0B-9E82-E7E0115DE05B}" type="datetimeFigureOut">
               <a:rPr lang="en-US" smtClean="0"/>
-              <a:t>3/18/2026</a:t>
+              <a:t>5/3/2026</a:t>
             </a:fld>
             <a:endParaRPr lang="en-US"/>
           </a:p>
@@ -3297,7 +3450,7 @@
           <a:p>
             <a:fld id="{0560A9CD-0304-4E0B-9E82-E7E0115DE05B}" type="datetimeFigureOut">
               <a:rPr lang="en-US" smtClean="0"/>
-              <a:t>3/18/2026</a:t>
+              <a:t>5/3/2026</a:t>
             </a:fld>
             <a:endParaRPr lang="en-US"/>
           </a:p>
@@ -3392,7 +3545,7 @@
           <a:p>
             <a:fld id="{0560A9CD-0304-4E0B-9E82-E7E0115DE05B}" type="datetimeFigureOut">
               <a:rPr lang="en-US" smtClean="0"/>
-              <a:t>3/18/2026</a:t>
+              <a:t>5/3/2026</a:t>
             </a:fld>
             <a:endParaRPr lang="en-US"/>
           </a:p>
@@ -3667,7 +3820,7 @@
           <a:p>
             <a:fld id="{0560A9CD-0304-4E0B-9E82-E7E0115DE05B}" type="datetimeFigureOut">
               <a:rPr lang="en-US" smtClean="0"/>
-              <a:t>3/18/2026</a:t>
+              <a:t>5/3/2026</a:t>
             </a:fld>
             <a:endParaRPr lang="en-US"/>
           </a:p>
@@ -3919,7 +4072,7 @@
           <a:p>
             <a:fld id="{0560A9CD-0304-4E0B-9E82-E7E0115DE05B}" type="datetimeFigureOut">
               <a:rPr lang="en-US" smtClean="0"/>
-              <a:t>3/18/2026</a:t>
+              <a:t>5/3/2026</a:t>
             </a:fld>
             <a:endParaRPr lang="en-US"/>
           </a:p>
@@ -4130,7 +4283,7 @@
           <a:p>
             <a:fld id="{0560A9CD-0304-4E0B-9E82-E7E0115DE05B}" type="datetimeFigureOut">
               <a:rPr lang="en-US" smtClean="0"/>
-              <a:t>3/18/2026</a:t>
+              <a:t>5/3/2026</a:t>
             </a:fld>
             <a:endParaRPr lang="en-US"/>
           </a:p>
@@ -5147,44 +5300,6 @@
           <a:chExt cx="0" cy="0"/>
         </a:xfrm>
       </p:grpSpPr>
-      <p:sp>
-        <p:nvSpPr>
-          <p:cNvPr id="2" name="Title 1"/>
-          <p:cNvSpPr>
-            <a:spLocks noGrp="1"/>
-          </p:cNvSpPr>
-          <p:nvPr>
-            <p:ph type="title"/>
-          </p:nvPr>
-        </p:nvSpPr>
-        <p:spPr/>
-        <p:txBody>
-          <a:bodyPr/>
-          <a:lstStyle/>
-          <a:p>
-            <a:endParaRPr lang="en-US"/>
-          </a:p>
-        </p:txBody>
-      </p:sp>
-      <p:sp>
-        <p:nvSpPr>
-          <p:cNvPr id="3" name="Content Placeholder 2"/>
-          <p:cNvSpPr>
-            <a:spLocks noGrp="1"/>
-          </p:cNvSpPr>
-          <p:nvPr>
-            <p:ph idx="1"/>
-          </p:nvPr>
-        </p:nvSpPr>
-        <p:spPr/>
-        <p:txBody>
-          <a:bodyPr/>
-          <a:lstStyle/>
-          <a:p>
-            <a:endParaRPr lang="en-US"/>
-          </a:p>
-        </p:txBody>
-      </p:sp>
       <p:graphicFrame>
         <p:nvGraphicFramePr>
           <p:cNvPr id="4" name="Table 3"/>
@@ -5194,14 +5309,14 @@
           <p:nvPr>
             <p:extLst>
               <p:ext uri="{D42A27DB-BD31-4B8C-83A1-F6EECF244321}">
-                <p14:modId xmlns:p14="http://schemas.microsoft.com/office/powerpoint/2010/main" val="3023884831"/>
+                <p14:modId xmlns:p14="http://schemas.microsoft.com/office/powerpoint/2010/main" val="2257607855"/>
               </p:ext>
             </p:extLst>
           </p:nvPr>
         </p:nvGraphicFramePr>
         <p:xfrm>
-          <a:off x="283446" y="365125"/>
-          <a:ext cx="11625107" cy="6080760"/>
+          <a:off x="283446" y="702007"/>
+          <a:ext cx="11625107" cy="5516880"/>
         </p:xfrm>
         <a:graphic>
           <a:graphicData uri="http://schemas.openxmlformats.org/drawingml/2006/table">
@@ -5324,30 +5439,7 @@
                           <a:latin typeface="Courier New" panose="02070309020205020404" pitchFamily="49" charset="0"/>
                           <a:cs typeface="Courier New" panose="02070309020205020404" pitchFamily="49" charset="0"/>
                         </a:rPr>
-                        <a:t>    def do_quit(self):</a:t>
-                      </a:r>
-                    </a:p>
-                    <a:p>
-                      <a:pPr>
-                        <a:spcAft>
-                          <a:spcPts val="600"/>
-                        </a:spcAft>
-                      </a:pPr>
-                      <a:r>
-                        <a:rPr lang="pt-BR" sz="1600" b="1" dirty="0">
-                          <a:latin typeface="Courier New" panose="02070309020205020404" pitchFamily="49" charset="0"/>
-                          <a:cs typeface="Courier New" panose="02070309020205020404" pitchFamily="49" charset="0"/>
-                        </a:rPr>
-                        <a:t>        self.root.destroy()</a:t>
-                      </a:r>
-                    </a:p>
-                    <a:p>
-                      <a:r>
-                        <a:rPr lang="pt-BR" sz="1600" b="1" dirty="0">
-                          <a:latin typeface="Courier New" panose="02070309020205020404" pitchFamily="49" charset="0"/>
-                          <a:cs typeface="Courier New" panose="02070309020205020404" pitchFamily="49" charset="0"/>
-                        </a:rPr>
-                        <a:t>    def add(self, x):</a:t>
+                        <a:t>def add(self, x):</a:t>
                       </a:r>
                     </a:p>
                     <a:p>
@@ -5743,7 +5835,7 @@
         </p:blipFill>
         <p:spPr>
           <a:xfrm>
-            <a:off x="8564127" y="1027906"/>
+            <a:off x="8564127" y="1364788"/>
             <a:ext cx="3067050" cy="1123950"/>
           </a:xfrm>
           <a:prstGeom prst="rect">
@@ -5767,7 +5859,7 @@
         </p:blipFill>
         <p:spPr>
           <a:xfrm>
-            <a:off x="8564127" y="2353469"/>
+            <a:off x="8564127" y="2690351"/>
             <a:ext cx="3067050" cy="1123950"/>
           </a:xfrm>
           <a:prstGeom prst="rect">
@@ -14683,8 +14775,68 @@
         </p:blipFill>
         <p:spPr>
           <a:xfrm>
-            <a:off x="0" y="-55342"/>
+            <a:off x="0" y="-83013"/>
             <a:ext cx="12192000" cy="6913342"/>
+          </a:xfrm>
+          <a:prstGeom prst="rect">
+            <a:avLst/>
+          </a:prstGeom>
+        </p:spPr>
+      </p:pic>
+      <p:pic>
+        <p:nvPicPr>
+          <p:cNvPr id="3" name="Picture 2">
+            <a:extLst>
+              <a:ext uri="{FF2B5EF4-FFF2-40B4-BE49-F238E27FC236}">
+                <a16:creationId xmlns:a16="http://schemas.microsoft.com/office/drawing/2014/main" id="{19C8794E-A018-4433-B6EB-3B14B3ABBA1D}"/>
+              </a:ext>
+            </a:extLst>
+          </p:cNvPr>
+          <p:cNvPicPr>
+            <a:picLocks noChangeAspect="1"/>
+          </p:cNvPicPr>
+          <p:nvPr/>
+        </p:nvPicPr>
+        <p:blipFill>
+          <a:blip r:embed="rId3"/>
+          <a:stretch>
+            <a:fillRect/>
+          </a:stretch>
+        </p:blipFill>
+        <p:spPr>
+          <a:xfrm>
+            <a:off x="0" y="-27671"/>
+            <a:ext cx="12192000" cy="6858000"/>
+          </a:xfrm>
+          <a:prstGeom prst="rect">
+            <a:avLst/>
+          </a:prstGeom>
+        </p:spPr>
+      </p:pic>
+      <p:pic>
+        <p:nvPicPr>
+          <p:cNvPr id="10" name="Picture 9">
+            <a:extLst>
+              <a:ext uri="{FF2B5EF4-FFF2-40B4-BE49-F238E27FC236}">
+                <a16:creationId xmlns:a16="http://schemas.microsoft.com/office/drawing/2014/main" id="{3D55E4ED-F300-A147-432D-3733BD3DC8FE}"/>
+              </a:ext>
+            </a:extLst>
+          </p:cNvPr>
+          <p:cNvPicPr>
+            <a:picLocks noChangeAspect="1"/>
+          </p:cNvPicPr>
+          <p:nvPr/>
+        </p:nvPicPr>
+        <p:blipFill>
+          <a:blip r:embed="rId4"/>
+          <a:stretch>
+            <a:fillRect/>
+          </a:stretch>
+        </p:blipFill>
+        <p:spPr>
+          <a:xfrm>
+            <a:off x="0" y="0"/>
+            <a:ext cx="12192000" cy="6858000"/>
           </a:xfrm>
           <a:prstGeom prst="rect">
             <a:avLst/>
@@ -14737,36 +14889,6 @@
           </a:p>
         </p:txBody>
       </p:sp>
-      <p:pic>
-        <p:nvPicPr>
-          <p:cNvPr id="3" name="Picture 2">
-            <a:extLst>
-              <a:ext uri="{FF2B5EF4-FFF2-40B4-BE49-F238E27FC236}">
-                <a16:creationId xmlns:a16="http://schemas.microsoft.com/office/drawing/2014/main" id="{19C8794E-A018-4433-B6EB-3B14B3ABBA1D}"/>
-              </a:ext>
-            </a:extLst>
-          </p:cNvPr>
-          <p:cNvPicPr>
-            <a:picLocks noChangeAspect="1"/>
-          </p:cNvPicPr>
-          <p:nvPr/>
-        </p:nvPicPr>
-        <p:blipFill>
-          <a:blip r:embed="rId3"/>
-          <a:stretch>
-            <a:fillRect/>
-          </a:stretch>
-        </p:blipFill>
-        <p:spPr>
-          <a:xfrm>
-            <a:off x="0" y="10510"/>
-            <a:ext cx="12192000" cy="6858000"/>
-          </a:xfrm>
-          <a:prstGeom prst="rect">
-            <a:avLst/>
-          </a:prstGeom>
-        </p:spPr>
-      </p:pic>
     </p:spTree>
     <p:extLst>
       <p:ext uri="{BB962C8B-B14F-4D97-AF65-F5344CB8AC3E}">

</xml_diff>